<commit_message>
feat: Integrate Utterances comments for GitHub Issues on video detail pages
</commit_message>
<xml_diff>
--- a/docs/rick-astley-never-gonna-give-you-up.pptx
+++ b/docs/rick-astley-never-gonna-give-you-up.pptx
@@ -3313,7 +3313,7 @@
               </a:defRPr>
             </a:pPr>
             <a:r>
-              <a:t>▸ 상대방을 울리거나 거짓말을 하지 않고, 어떤 식으로든 상처 주지 않겠다는 진실된 마음과 보호 의지를 약속합니다.</a:t>
+              <a:t>▸ 상대방을 울리거나 거짓말을 하지 않고, 어떤 식으로든 상처 주지 않겠다는 진심된 마음과 보호 의지를 약속합니다.</a:t>
             </a:r>
           </a:p>
           <a:p>
@@ -3329,7 +3329,7 @@
               </a:defRPr>
             </a:pPr>
             <a:r>
-              <a:t>▸ 80년대 팝 음악의 상징적인 곡으로, 경쾌한 멜로디와 중독성 있는 후렴구로 전 세계적인 사랑을 받아왔습니다.</a:t>
+              <a:t>▸ 80년대 팝 음악의 상징적인 곡으로, 경쾌한 멜로디 and 중독성 있는 후렴구로 전 세계적인 사랑을 받아왔습니다.</a:t>
             </a:r>
           </a:p>
           <a:p>

</xml_diff>